<commit_message>
Slaytlara konuyla ilgili tema videosu ekle (YouTube gomulu)
Her unitenin sunumuna, konu anlatimi degil konuyla tematik olarak
iliskili (ilahi, animasyon, belgesel) bir YouTube videosu gomuldu.
Videolar baslik/icerik uygunluguna gore secildi.
</commit_message>
<xml_diff>
--- a/slayt1.pptx
+++ b/slayt1.pptx
@@ -22,9 +22,10 @@
     <p:sldId id="270" r:id="rId16"/>
     <p:sldId id="271" r:id="rId17"/>
     <p:sldId id="272" r:id="rId18"/>
+    <p:sldId id="273" r:id="rId19"/>
   </p:sldIdLst>
   <p:notesMasterIdLst>
-    <p:notesMasterId r:id="rId19"/>
+    <p:notesMasterId r:id="rId20"/>
   </p:notesMasterIdLst>
   <p:sldSz cx="9144000" cy="5143500"/>
   <p:notesSz cx="5143500" cy="9144000"/>
@@ -1264,6 +1265,94 @@
 </p:notes>
 </file>
 
+<file path=ppt/notesSlides/notesSlide18.xml><?xml version="1.0" encoding="utf-8"?>
+<p:notes xmlns:a="http://schemas.openxmlformats.org/drawingml/2006/main" xmlns:r="http://schemas.openxmlformats.org/officeDocument/2006/relationships" xmlns:p="http://schemas.openxmlformats.org/presentationml/2006/main">
+  <p:cSld>
+    <p:spTree>
+      <p:nvGrpSpPr>
+        <p:cNvPr id="1" name=""/>
+        <p:cNvGrpSpPr/>
+        <p:nvPr/>
+      </p:nvGrpSpPr>
+      <p:grpSpPr>
+        <a:xfrm>
+          <a:off x="0" y="0"/>
+          <a:ext cx="0" cy="0"/>
+          <a:chOff x="0" y="0"/>
+          <a:chExt cx="0" cy="0"/>
+        </a:xfrm>
+      </p:grpSpPr>
+      <p:sp>
+        <p:nvSpPr>
+          <p:cNvPr id="2" name="Slide Image Placeholder 1"/>
+          <p:cNvSpPr>
+            <a:spLocks noGrp="1" noRot="1" noChangeAspect="1"/>
+          </p:cNvSpPr>
+          <p:nvPr>
+            <p:ph type="sldImg"/>
+          </p:nvPr>
+        </p:nvSpPr>
+        <p:spPr/>
+      </p:sp>
+      <p:sp>
+        <p:nvSpPr>
+          <p:cNvPr id="3" name="Notes Placeholder 2"/>
+          <p:cNvSpPr>
+            <a:spLocks noGrp="1"/>
+          </p:cNvSpPr>
+          <p:nvPr>
+            <p:ph type="body" idx="1"/>
+          </p:nvPr>
+        </p:nvSpPr>
+        <p:spPr/>
+        <p:txBody>
+          <a:bodyPr/>
+          <a:lstStyle/>
+          <a:p>
+            <a:r>
+              <a:rPr lang="en-US" dirty="0"/>
+              <a:t/>
+            </a:r>
+            <a:endParaRPr lang="en-US" dirty="0"/>
+          </a:p>
+        </p:txBody>
+      </p:sp>
+      <p:sp>
+        <p:nvSpPr>
+          <p:cNvPr id="4" name="Slide Number Placeholder 3"/>
+          <p:cNvSpPr>
+            <a:spLocks noGrp="1"/>
+          </p:cNvSpPr>
+          <p:nvPr>
+            <p:ph type="sldNum" sz="quarter" idx="10"/>
+          </p:nvPr>
+        </p:nvSpPr>
+        <p:spPr/>
+        <p:txBody>
+          <a:bodyPr/>
+          <a:lstStyle/>
+          <a:p>
+            <a:fld id="{F7021451-1387-4CA6-816F-3879F97B5CBC}" type="slidenum">
+              <a:rPr lang="en-US"/>
+              <a:t>18</a:t>
+            </a:fld>
+            <a:endParaRPr lang="en-US"/>
+          </a:p>
+        </p:txBody>
+      </p:sp>
+    </p:spTree>
+    <p:extLst>
+      <p:ext uri="{BB962C8B-B14F-4D97-AF65-F5344CB8AC3E}">
+        <p14:creationId xmlns:p14="http://schemas.microsoft.com/office/powerpoint/2010/main" val="1024086991"/>
+      </p:ext>
+    </p:extLst>
+  </p:cSld>
+  <p:clrMapOvr>
+    <a:masterClrMapping/>
+  </p:clrMapOvr>
+</p:notes>
+</file>
+
 <file path=ppt/notesSlides/notesSlide2.xml><?xml version="1.0" encoding="utf-8"?>
 <p:notes xmlns:a="http://schemas.openxmlformats.org/drawingml/2006/main" xmlns:r="http://schemas.openxmlformats.org/officeDocument/2006/relationships" xmlns:p="http://schemas.openxmlformats.org/presentationml/2006/main">
   <p:cSld>
@@ -3634,7 +3723,7 @@
         <p:spPr>
           <a:xfrm>
             <a:off x="0" y="5116068"/>
-            <a:ext cx="5378824" cy="32004"/>
+            <a:ext cx="5080000" cy="32004"/>
           </a:xfrm>
           <a:prstGeom prst="rect">
             <a:avLst/>
@@ -4219,7 +4308,7 @@
         <p:spPr>
           <a:xfrm>
             <a:off x="0" y="5116068"/>
-            <a:ext cx="5916706" cy="32004"/>
+            <a:ext cx="5588000" cy="32004"/>
           </a:xfrm>
           <a:prstGeom prst="rect">
             <a:avLst/>
@@ -5190,7 +5279,7 @@
         <p:spPr>
           <a:xfrm>
             <a:off x="0" y="5116068"/>
-            <a:ext cx="6454588" cy="32004"/>
+            <a:ext cx="6096000" cy="32004"/>
           </a:xfrm>
           <a:prstGeom prst="rect">
             <a:avLst/>
@@ -5617,7 +5706,7 @@
         <p:spPr>
           <a:xfrm>
             <a:off x="0" y="5116068"/>
-            <a:ext cx="6992471" cy="32004"/>
+            <a:ext cx="6604000" cy="32004"/>
           </a:xfrm>
           <a:prstGeom prst="rect">
             <a:avLst/>
@@ -6039,7 +6128,7 @@
         <p:spPr>
           <a:xfrm>
             <a:off x="0" y="5116068"/>
-            <a:ext cx="7530353" cy="32004"/>
+            <a:ext cx="7112000" cy="32004"/>
           </a:xfrm>
           <a:prstGeom prst="rect">
             <a:avLst/>
@@ -6461,7 +6550,7 @@
         <p:spPr>
           <a:xfrm>
             <a:off x="0" y="5116068"/>
-            <a:ext cx="8068235" cy="32004"/>
+            <a:ext cx="7620000" cy="32004"/>
           </a:xfrm>
           <a:prstGeom prst="rect">
             <a:avLst/>
@@ -6483,6 +6572,352 @@
 <file path=ppt/slides/slide16.xml><?xml version="1.0" encoding="utf-8"?>
 <p:sld xmlns:a="http://schemas.openxmlformats.org/drawingml/2006/main" xmlns:r="http://schemas.openxmlformats.org/officeDocument/2006/relationships" xmlns:p="http://schemas.openxmlformats.org/presentationml/2006/main">
   <p:cSld name="Slide 16">
+    <p:bg>
+      <p:bgPr>
+        <a:solidFill>
+          <a:srgbClr val="1B3A4B"/>
+        </a:solidFill>
+      </p:bgPr>
+    </p:bg>
+    <p:spTree>
+      <p:nvGrpSpPr>
+        <p:cNvPr id="1" name=""/>
+        <p:cNvGrpSpPr/>
+        <p:nvPr/>
+      </p:nvGrpSpPr>
+      <p:grpSpPr>
+        <a:xfrm>
+          <a:off x="0" y="0"/>
+          <a:ext cx="0" cy="0"/>
+          <a:chOff x="0" y="0"/>
+          <a:chExt cx="0" cy="0"/>
+        </a:xfrm>
+      </p:grpSpPr>
+      <p:sp>
+        <p:nvSpPr>
+          <p:cNvPr id="2" name="Shape 0"/>
+          <p:cNvSpPr/>
+          <p:nvPr/>
+        </p:nvSpPr>
+        <p:spPr>
+          <a:xfrm>
+            <a:off x="-1188720" y="-1188720"/>
+            <a:ext cx="2926080" cy="2926080"/>
+          </a:xfrm>
+          <a:prstGeom prst="ellipse">
+            <a:avLst/>
+          </a:prstGeom>
+          <a:solidFill>
+            <a:srgbClr val="2E7D5B">
+              <a:alpha val="18000"/>
+            </a:srgbClr>
+          </a:solidFill>
+          <a:ln/>
+        </p:spPr>
+      </p:sp>
+      <p:sp>
+        <p:nvSpPr>
+          <p:cNvPr id="3" name="Shape 1"/>
+          <p:cNvSpPr/>
+          <p:nvPr/>
+        </p:nvSpPr>
+        <p:spPr>
+          <a:xfrm>
+            <a:off x="7589520" y="3291840"/>
+            <a:ext cx="2743200" cy="2743200"/>
+          </a:xfrm>
+          <a:prstGeom prst="ellipse">
+            <a:avLst/>
+          </a:prstGeom>
+          <a:solidFill>
+            <a:srgbClr val="2E7D5B">
+              <a:alpha val="15000"/>
+            </a:srgbClr>
+          </a:solidFill>
+          <a:ln/>
+        </p:spPr>
+      </p:sp>
+      <p:sp>
+        <p:nvSpPr>
+          <p:cNvPr id="4" name="Shape 2"/>
+          <p:cNvSpPr/>
+          <p:nvPr/>
+        </p:nvSpPr>
+        <p:spPr>
+          <a:xfrm>
+            <a:off x="8138160" y="-731520"/>
+            <a:ext cx="1463040" cy="1463040"/>
+          </a:xfrm>
+          <a:prstGeom prst="ellipse">
+            <a:avLst/>
+          </a:prstGeom>
+          <a:solidFill>
+            <a:srgbClr val="B8860B">
+              <a:alpha val="20000"/>
+            </a:srgbClr>
+          </a:solidFill>
+          <a:ln/>
+        </p:spPr>
+      </p:sp>
+      <p:sp>
+        <p:nvSpPr>
+          <p:cNvPr id="5" name="Text 3"/>
+          <p:cNvSpPr/>
+          <p:nvPr/>
+        </p:nvSpPr>
+        <p:spPr>
+          <a:xfrm>
+            <a:off x="457200" y="292608"/>
+            <a:ext cx="8229600" cy="411480"/>
+          </a:xfrm>
+          <a:prstGeom prst="rect">
+            <a:avLst/>
+          </a:prstGeom>
+          <a:noFill/>
+          <a:ln/>
+        </p:spPr>
+        <p:txBody>
+          <a:bodyPr wrap="square" rtlCol="0" anchor="ctr"/>
+          <a:lstStyle/>
+          <a:p>
+            <a:pPr algn="ctr" indent="0" marL="0">
+              <a:buNone/>
+            </a:pPr>
+            <a:r>
+              <a:rPr lang="en-US" sz="1600" b="1" spc="200" kern="0" dirty="0">
+                <a:solidFill>
+                  <a:srgbClr val="8FD9B8"/>
+                </a:solidFill>
+                <a:latin typeface="Calibri" pitchFamily="34" charset="0"/>
+                <a:ea typeface="Calibri" pitchFamily="34" charset="-122"/>
+                <a:cs typeface="Calibri" pitchFamily="34" charset="-120"/>
+              </a:rPr>
+              <a:t>🎬 KONUYLA İLGİLİ VİDEO</a:t>
+            </a:r>
+            <a:endParaRPr lang="en-US" sz="1600" dirty="0"/>
+          </a:p>
+        </p:txBody>
+      </p:sp>
+      <p:sp>
+        <p:nvSpPr>
+          <p:cNvPr id="6" name="Shape 4"/>
+          <p:cNvSpPr/>
+          <p:nvPr/>
+        </p:nvSpPr>
+        <p:spPr>
+          <a:xfrm>
+            <a:off x="914400" y="868680"/>
+            <a:ext cx="7315200" cy="3703320"/>
+          </a:xfrm>
+          <a:prstGeom prst="roundRect">
+            <a:avLst>
+              <a:gd name="adj" fmla="val 1481"/>
+            </a:avLst>
+          </a:prstGeom>
+          <a:solidFill>
+            <a:srgbClr val="000000"/>
+          </a:solidFill>
+          <a:ln w="25400">
+            <a:solidFill>
+              <a:srgbClr val="B8860B"/>
+            </a:solidFill>
+            <a:prstDash val="solid"/>
+          </a:ln>
+        </p:spPr>
+      </p:sp>
+      <p:pic>
+        <p:nvPicPr>
+          <p:cNvPr id="3" name="Media 0"/>
+          <p:cNvPicPr/>
+          <p:nvPr>
+            <a:videoFile r:link="rId1"/>
+          </p:nvPr>
+        </p:nvPicPr>
+        <p:blipFill>
+          <a:blip r:embed="rId2"/>
+          <a:stretch>
+            <a:fillRect/>
+          </a:stretch>
+        </p:blipFill>
+        <p:spPr>
+          <a:xfrm>
+            <a:off x="987552" y="941832"/>
+            <a:ext cx="7168896" cy="3291840"/>
+          </a:xfrm>
+          <a:prstGeom prst="rect">
+            <a:avLst/>
+          </a:prstGeom>
+        </p:spPr>
+      </p:pic>
+      <p:sp>
+        <p:nvSpPr>
+          <p:cNvPr id="8" name="Text 5"/>
+          <p:cNvSpPr/>
+          <p:nvPr/>
+        </p:nvSpPr>
+        <p:spPr>
+          <a:xfrm>
+            <a:off x="914400" y="4251960"/>
+            <a:ext cx="7315200" cy="320040"/>
+          </a:xfrm>
+          <a:prstGeom prst="rect">
+            <a:avLst/>
+          </a:prstGeom>
+          <a:noFill/>
+          <a:ln/>
+        </p:spPr>
+        <p:txBody>
+          <a:bodyPr wrap="square" rtlCol="0" anchor="ctr"/>
+          <a:lstStyle/>
+          <a:p>
+            <a:pPr algn="ctr" indent="0" marL="0">
+              <a:buNone/>
+            </a:pPr>
+            <a:r>
+              <a:rPr lang="en-US" sz="1200" i="1" dirty="0">
+                <a:solidFill>
+                  <a:srgbClr val="CCCCCC"/>
+                </a:solidFill>
+                <a:latin typeface="Calibri" pitchFamily="34" charset="0"/>
+                <a:ea typeface="Calibri" pitchFamily="34" charset="-122"/>
+                <a:cs typeface="Calibri" pitchFamily="34" charset="-120"/>
+              </a:rPr>
+              <a:t>Çocuk İlahileri | Bibercik İlahileri</a:t>
+            </a:r>
+            <a:endParaRPr lang="en-US" sz="1200" dirty="0"/>
+          </a:p>
+        </p:txBody>
+      </p:sp>
+      <p:sp>
+        <p:nvSpPr>
+          <p:cNvPr id="9" name="Text 6"/>
+          <p:cNvSpPr/>
+          <p:nvPr/>
+        </p:nvSpPr>
+        <p:spPr>
+          <a:xfrm>
+            <a:off x="274320" y="4882896"/>
+            <a:ext cx="6858000" cy="228600"/>
+          </a:xfrm>
+          <a:prstGeom prst="rect">
+            <a:avLst/>
+          </a:prstGeom>
+          <a:noFill/>
+          <a:ln/>
+        </p:spPr>
+        <p:txBody>
+          <a:bodyPr wrap="square" rtlCol="0" anchor="ctr"/>
+          <a:lstStyle/>
+          <a:p>
+            <a:pPr indent="0" marL="0">
+              <a:buNone/>
+            </a:pPr>
+            <a:r>
+              <a:rPr lang="en-US" sz="900" dirty="0">
+                <a:solidFill>
+                  <a:srgbClr val="999999"/>
+                </a:solidFill>
+                <a:latin typeface="Calibri" pitchFamily="34" charset="0"/>
+                <a:ea typeface="Calibri" pitchFamily="34" charset="-122"/>
+                <a:cs typeface="Calibri" pitchFamily="34" charset="-120"/>
+              </a:rPr>
+              <a:t>4. Sınıf DKAB — Günlük Hayattaki Dinî İfadeler</a:t>
+            </a:r>
+            <a:endParaRPr lang="en-US" sz="900" dirty="0"/>
+          </a:p>
+        </p:txBody>
+      </p:sp>
+      <p:sp>
+        <p:nvSpPr>
+          <p:cNvPr id="10" name="Text 7"/>
+          <p:cNvSpPr/>
+          <p:nvPr/>
+        </p:nvSpPr>
+        <p:spPr>
+          <a:xfrm>
+            <a:off x="8366760" y="4828032"/>
+            <a:ext cx="502920" cy="292608"/>
+          </a:xfrm>
+          <a:prstGeom prst="roundRect">
+            <a:avLst>
+              <a:gd name="adj" fmla="val 18750"/>
+            </a:avLst>
+          </a:prstGeom>
+          <a:solidFill>
+            <a:srgbClr val="2E7D5B"/>
+          </a:solidFill>
+          <a:ln/>
+        </p:spPr>
+        <p:txBody>
+          <a:bodyPr wrap="square" rtlCol="0" anchor="ctr"/>
+          <a:lstStyle/>
+          <a:p>
+            <a:pPr algn="ctr" indent="0" marL="0">
+              <a:buNone/>
+            </a:pPr>
+            <a:r>
+              <a:rPr lang="en-US" sz="1000" b="1" dirty="0">
+                <a:solidFill>
+                  <a:srgbClr val="FFFFFF"/>
+                </a:solidFill>
+              </a:rPr>
+              <a:t>16</a:t>
+            </a:r>
+            <a:endParaRPr lang="en-US" sz="1000" dirty="0"/>
+          </a:p>
+        </p:txBody>
+      </p:sp>
+      <p:sp>
+        <p:nvSpPr>
+          <p:cNvPr id="11" name="Shape 8"/>
+          <p:cNvSpPr/>
+          <p:nvPr/>
+        </p:nvSpPr>
+        <p:spPr>
+          <a:xfrm>
+            <a:off x="0" y="5116068"/>
+            <a:ext cx="9144000" cy="32004"/>
+          </a:xfrm>
+          <a:prstGeom prst="rect">
+            <a:avLst/>
+          </a:prstGeom>
+          <a:solidFill>
+            <a:srgbClr val="E5E0D0"/>
+          </a:solidFill>
+          <a:ln/>
+        </p:spPr>
+      </p:sp>
+      <p:sp>
+        <p:nvSpPr>
+          <p:cNvPr id="12" name="Shape 9"/>
+          <p:cNvSpPr/>
+          <p:nvPr/>
+        </p:nvSpPr>
+        <p:spPr>
+          <a:xfrm>
+            <a:off x="0" y="5116068"/>
+            <a:ext cx="8128000" cy="32004"/>
+          </a:xfrm>
+          <a:prstGeom prst="rect">
+            <a:avLst/>
+          </a:prstGeom>
+          <a:solidFill>
+            <a:srgbClr val="2E7D5B"/>
+          </a:solidFill>
+          <a:ln/>
+        </p:spPr>
+      </p:sp>
+    </p:spTree>
+  </p:cSld>
+  <p:clrMapOvr>
+    <a:masterClrMapping/>
+  </p:clrMapOvr>
+</p:sld>
+</file>
+
+<file path=ppt/slides/slide17.xml><?xml version="1.0" encoding="utf-8"?>
+<p:sld xmlns:a="http://schemas.openxmlformats.org/drawingml/2006/main" xmlns:r="http://schemas.openxmlformats.org/officeDocument/2006/relationships" xmlns:p="http://schemas.openxmlformats.org/presentationml/2006/main">
+  <p:cSld name="Slide 17">
     <p:bg>
       <p:bgPr>
         <a:solidFill>
@@ -7452,7 +7887,7 @@
                   <a:srgbClr val="FFFFFF"/>
                 </a:solidFill>
               </a:rPr>
-              <a:t>16</a:t>
+              <a:t>17</a:t>
             </a:r>
             <a:endParaRPr lang="en-US" sz="1000" dirty="0"/>
           </a:p>
@@ -7487,7 +7922,7 @@
         <p:spPr>
           <a:xfrm>
             <a:off x="0" y="5116068"/>
-            <a:ext cx="8606118" cy="32004"/>
+            <a:ext cx="8636000" cy="32004"/>
           </a:xfrm>
           <a:prstGeom prst="rect">
             <a:avLst/>
@@ -7506,9 +7941,9 @@
 </p:sld>
 </file>
 
-<file path=ppt/slides/slide17.xml><?xml version="1.0" encoding="utf-8"?>
+<file path=ppt/slides/slide18.xml><?xml version="1.0" encoding="utf-8"?>
 <p:sld xmlns:a="http://schemas.openxmlformats.org/drawingml/2006/main" xmlns:r="http://schemas.openxmlformats.org/officeDocument/2006/relationships" xmlns:p="http://schemas.openxmlformats.org/presentationml/2006/main">
-  <p:cSld name="Slide 17">
+  <p:cSld name="Slide 18">
     <p:bg>
       <p:bgPr>
         <a:solidFill>
@@ -8848,7 +9283,7 @@
         <p:spPr>
           <a:xfrm>
             <a:off x="0" y="5116068"/>
-            <a:ext cx="1075765" cy="32004"/>
+            <a:ext cx="1016000" cy="32004"/>
           </a:xfrm>
           <a:prstGeom prst="rect">
             <a:avLst/>
@@ -9874,7 +10309,7 @@
         <p:spPr>
           <a:xfrm>
             <a:off x="0" y="5116068"/>
-            <a:ext cx="1613647" cy="32004"/>
+            <a:ext cx="1524000" cy="32004"/>
           </a:xfrm>
           <a:prstGeom prst="rect">
             <a:avLst/>
@@ -10900,7 +11335,7 @@
         <p:spPr>
           <a:xfrm>
             <a:off x="0" y="5116068"/>
-            <a:ext cx="2151529" cy="32004"/>
+            <a:ext cx="2032000" cy="32004"/>
           </a:xfrm>
           <a:prstGeom prst="rect">
             <a:avLst/>
@@ -11926,7 +12361,7 @@
         <p:spPr>
           <a:xfrm>
             <a:off x="0" y="5116068"/>
-            <a:ext cx="2689412" cy="32004"/>
+            <a:ext cx="2540000" cy="32004"/>
           </a:xfrm>
           <a:prstGeom prst="rect">
             <a:avLst/>
@@ -12658,7 +13093,7 @@
         <p:spPr>
           <a:xfrm>
             <a:off x="0" y="5116068"/>
-            <a:ext cx="3227294" cy="32004"/>
+            <a:ext cx="3048000" cy="32004"/>
           </a:xfrm>
           <a:prstGeom prst="rect">
             <a:avLst/>
@@ -13390,7 +13825,7 @@
         <p:spPr>
           <a:xfrm>
             <a:off x="0" y="5116068"/>
-            <a:ext cx="3765176" cy="32004"/>
+            <a:ext cx="3556000" cy="32004"/>
           </a:xfrm>
           <a:prstGeom prst="rect">
             <a:avLst/>
@@ -14416,7 +14851,7 @@
         <p:spPr>
           <a:xfrm>
             <a:off x="0" y="5116068"/>
-            <a:ext cx="4303059" cy="32004"/>
+            <a:ext cx="4064000" cy="32004"/>
           </a:xfrm>
           <a:prstGeom prst="rect">
             <a:avLst/>
@@ -15001,7 +15436,7 @@
         <p:spPr>
           <a:xfrm>
             <a:off x="0" y="5116068"/>
-            <a:ext cx="4840941" cy="32004"/>
+            <a:ext cx="4572000" cy="32004"/>
           </a:xfrm>
           <a:prstGeom prst="rect">
             <a:avLst/>

</xml_diff>

<commit_message>
Video slaydini gomulu oynaticidan tiklanabilir karta cevir
Online video gomme (addMedia) PowerPoint masaustunde guvenilir
calismadigi icin, video slaydi artik buyuk bir oynat ikonu +
hyperlink iceren tiklanabilir kart: tiklaninca YouTube tarayicida
acilir. Butun PowerPoint surumlerinde calisir.
</commit_message>
<xml_diff>
--- a/slayt1.pptx
+++ b/slayt1.pptx
@@ -6700,22 +6700,24 @@
       </p:sp>
       <p:sp>
         <p:nvSpPr>
-          <p:cNvPr id="6" name="Shape 4"/>
+          <p:cNvPr id="6" name="Shape 4">
+            <a:hlinkClick r:id="rId1" tooltip="YouTube'da izlemek için tıklayın"/>
+          </p:cNvPr>
           <p:cNvSpPr/>
           <p:nvPr/>
         </p:nvSpPr>
         <p:spPr>
           <a:xfrm>
             <a:off x="914400" y="868680"/>
-            <a:ext cx="7315200" cy="3703320"/>
+            <a:ext cx="7315200" cy="3246120"/>
           </a:xfrm>
           <a:prstGeom prst="roundRect">
             <a:avLst>
-              <a:gd name="adj" fmla="val 1481"/>
+              <a:gd name="adj" fmla="val 1690"/>
             </a:avLst>
           </a:prstGeom>
           <a:solidFill>
-            <a:srgbClr val="000000"/>
+            <a:srgbClr val="0B0B0B"/>
           </a:solidFill>
           <a:ln w="25400">
             <a:solidFill>
@@ -6725,40 +6727,45 @@
           </a:ln>
         </p:spPr>
       </p:sp>
-      <p:pic>
-        <p:nvPicPr>
-          <p:cNvPr id="3" name="Media 0"/>
-          <p:cNvPicPr/>
-          <p:nvPr>
-            <a:videoFile r:link="rId1"/>
-          </p:nvPr>
-        </p:nvPicPr>
-        <p:blipFill>
-          <a:blip r:embed="rId2"/>
-          <a:stretch>
-            <a:fillRect/>
-          </a:stretch>
-        </p:blipFill>
-        <p:spPr>
-          <a:xfrm>
-            <a:off x="987552" y="941832"/>
-            <a:ext cx="7168896" cy="3291840"/>
-          </a:xfrm>
-          <a:prstGeom prst="rect">
-            <a:avLst/>
-          </a:prstGeom>
-        </p:spPr>
-      </p:pic>
-      <p:sp>
-        <p:nvSpPr>
-          <p:cNvPr id="8" name="Text 5"/>
-          <p:cNvSpPr/>
-          <p:nvPr/>
-        </p:nvSpPr>
-        <p:spPr>
-          <a:xfrm>
-            <a:off x="914400" y="4251960"/>
-            <a:ext cx="7315200" cy="320040"/>
+      <p:sp>
+        <p:nvSpPr>
+          <p:cNvPr id="7" name="Shape 5">
+            <a:hlinkClick r:id="rId1" tooltip="YouTube'da izlemek için tıklayın"/>
+          </p:cNvPr>
+          <p:cNvSpPr/>
+          <p:nvPr/>
+        </p:nvSpPr>
+        <p:spPr>
+          <a:xfrm>
+            <a:off x="3977640" y="1920240"/>
+            <a:ext cx="1188720" cy="1188720"/>
+          </a:xfrm>
+          <a:prstGeom prst="ellipse">
+            <a:avLst/>
+          </a:prstGeom>
+          <a:solidFill>
+            <a:srgbClr val="E62117"/>
+          </a:solidFill>
+          <a:ln w="25400">
+            <a:solidFill>
+              <a:srgbClr val="FFFFFF"/>
+            </a:solidFill>
+            <a:prstDash val="solid"/>
+          </a:ln>
+        </p:spPr>
+      </p:sp>
+      <p:sp>
+        <p:nvSpPr>
+          <p:cNvPr id="8" name="Text 6">
+            <a:hlinkClick r:id="rId1" tooltip="YouTube'da izlemek için tıklayın"/>
+          </p:cNvPr>
+          <p:cNvSpPr/>
+          <p:nvPr/>
+        </p:nvSpPr>
+        <p:spPr>
+          <a:xfrm>
+            <a:off x="3977640" y="1920240"/>
+            <a:ext cx="1188720" cy="1188720"/>
           </a:xfrm>
           <a:prstGeom prst="rect">
             <a:avLst/>
@@ -6774,52 +6781,152 @@
               <a:buNone/>
             </a:pPr>
             <a:r>
-              <a:rPr lang="en-US" sz="1200" i="1" dirty="0">
-                <a:solidFill>
-                  <a:srgbClr val="CCCCCC"/>
+              <a:rPr lang="en-US" sz="3600" u="sng" dirty="0">
+                <a:solidFill>
+                  <a:srgbClr val="FFFFFF"/>
+                </a:solidFill>
+                <a:hlinkClick r:id="rId1" invalidUrl="" action="" tgtFrame="" tooltip="YouTube'da izlemek için tıklayın" history="1" highlightClick="0" endSnd="0">
+                  <a:extLst>
+                    <a:ext uri="{A12FA001-AC4F-418D-AE19-62706E023703}">
+                      <ahyp:hlinkClr xmlns:ahyp="http://schemas.microsoft.com/office/drawing/2018/hyperlinkcolor" val="tx"/>
+                    </a:ext>
+                  </a:extLst>
+                </a:hlinkClick>
+              </a:rPr>
+              <a:t>▶</a:t>
+            </a:r>
+            <a:endParaRPr lang="en-US" sz="3600" dirty="0"/>
+          </a:p>
+        </p:txBody>
+      </p:sp>
+      <p:sp>
+        <p:nvSpPr>
+          <p:cNvPr id="9" name="Text 7">
+            <a:hlinkClick r:id="rId1" tooltip="YouTube'da izlemek için tıklayın"/>
+          </p:cNvPr>
+          <p:cNvSpPr/>
+          <p:nvPr/>
+        </p:nvSpPr>
+        <p:spPr>
+          <a:xfrm>
+            <a:off x="1188720" y="3291840"/>
+            <a:ext cx="6766560" cy="640080"/>
+          </a:xfrm>
+          <a:prstGeom prst="rect">
+            <a:avLst/>
+          </a:prstGeom>
+          <a:noFill/>
+          <a:ln/>
+        </p:spPr>
+        <p:txBody>
+          <a:bodyPr wrap="square" rtlCol="0" anchor="ctr"/>
+          <a:lstStyle/>
+          <a:p>
+            <a:pPr algn="ctr" indent="0" marL="0">
+              <a:buNone/>
+            </a:pPr>
+            <a:r>
+              <a:rPr lang="en-US" sz="1600" b="1" u="sng" dirty="0">
+                <a:solidFill>
+                  <a:srgbClr val="FFFFFF"/>
                 </a:solidFill>
                 <a:latin typeface="Calibri" pitchFamily="34" charset="0"/>
                 <a:ea typeface="Calibri" pitchFamily="34" charset="-122"/>
                 <a:cs typeface="Calibri" pitchFamily="34" charset="-120"/>
+                <a:hlinkClick r:id="rId1" invalidUrl="" action="" tgtFrame="" tooltip="YouTube'da izlemek için tıklayın" history="1" highlightClick="0" endSnd="0">
+                  <a:extLst>
+                    <a:ext uri="{A12FA001-AC4F-418D-AE19-62706E023703}">
+                      <ahyp:hlinkClr xmlns:ahyp="http://schemas.microsoft.com/office/drawing/2018/hyperlinkcolor" val="tx"/>
+                    </a:ext>
+                  </a:extLst>
+                </a:hlinkClick>
               </a:rPr>
               <a:t>Çocuk İlahileri | Bibercik İlahileri</a:t>
             </a:r>
-            <a:endParaRPr lang="en-US" sz="1200" dirty="0"/>
-          </a:p>
-        </p:txBody>
-      </p:sp>
-      <p:sp>
-        <p:nvSpPr>
-          <p:cNvPr id="9" name="Text 6"/>
-          <p:cNvSpPr/>
-          <p:nvPr/>
-        </p:nvSpPr>
-        <p:spPr>
-          <a:xfrm>
-            <a:off x="274320" y="4882896"/>
-            <a:ext cx="6858000" cy="228600"/>
-          </a:xfrm>
-          <a:prstGeom prst="rect">
-            <a:avLst/>
-          </a:prstGeom>
-          <a:noFill/>
-          <a:ln/>
-        </p:spPr>
-        <p:txBody>
-          <a:bodyPr wrap="square" rtlCol="0" anchor="ctr"/>
-          <a:lstStyle/>
-          <a:p>
-            <a:pPr indent="0" marL="0">
-              <a:buNone/>
-            </a:pPr>
-            <a:r>
-              <a:rPr lang="en-US" sz="900" dirty="0">
-                <a:solidFill>
-                  <a:srgbClr val="999999"/>
+            <a:endParaRPr lang="en-US" sz="1600" dirty="0"/>
+          </a:p>
+        </p:txBody>
+      </p:sp>
+      <p:sp>
+        <p:nvSpPr>
+          <p:cNvPr id="10" name="Text 8">
+            <a:hlinkClick r:id="rId1" tooltip="YouTube'da izlemek için tıklayın"/>
+          </p:cNvPr>
+          <p:cNvSpPr/>
+          <p:nvPr/>
+        </p:nvSpPr>
+        <p:spPr>
+          <a:xfrm>
+            <a:off x="914400" y="4206240"/>
+            <a:ext cx="7315200" cy="365760"/>
+          </a:xfrm>
+          <a:prstGeom prst="rect">
+            <a:avLst/>
+          </a:prstGeom>
+          <a:noFill/>
+          <a:ln/>
+        </p:spPr>
+        <p:txBody>
+          <a:bodyPr wrap="square" rtlCol="0" anchor="ctr"/>
+          <a:lstStyle/>
+          <a:p>
+            <a:pPr algn="ctr" indent="0" marL="0">
+              <a:buNone/>
+            </a:pPr>
+            <a:r>
+              <a:rPr lang="en-US" sz="1200" i="1" u="sng" dirty="0">
+                <a:solidFill>
+                  <a:srgbClr val="B8860B"/>
                 </a:solidFill>
                 <a:latin typeface="Calibri" pitchFamily="34" charset="0"/>
                 <a:ea typeface="Calibri" pitchFamily="34" charset="-122"/>
                 <a:cs typeface="Calibri" pitchFamily="34" charset="-120"/>
+                <a:hlinkClick r:id="rId1" invalidUrl="" action="" tgtFrame="" tooltip="YouTube'da izlemek için tıklayın" history="1" highlightClick="0" endSnd="0">
+                  <a:extLst>
+                    <a:ext uri="{A12FA001-AC4F-418D-AE19-62706E023703}">
+                      <ahyp:hlinkClr xmlns:ahyp="http://schemas.microsoft.com/office/drawing/2018/hyperlinkcolor" val="tx"/>
+                    </a:ext>
+                  </a:extLst>
+                </a:hlinkClick>
+              </a:rPr>
+              <a:t>👆 İzlemek için tıklayın (YouTube'da açılır)</a:t>
+            </a:r>
+            <a:endParaRPr lang="en-US" sz="1200" dirty="0"/>
+          </a:p>
+        </p:txBody>
+      </p:sp>
+      <p:sp>
+        <p:nvSpPr>
+          <p:cNvPr id="11" name="Text 9"/>
+          <p:cNvSpPr/>
+          <p:nvPr/>
+        </p:nvSpPr>
+        <p:spPr>
+          <a:xfrm>
+            <a:off x="274320" y="4882896"/>
+            <a:ext cx="6858000" cy="228600"/>
+          </a:xfrm>
+          <a:prstGeom prst="rect">
+            <a:avLst/>
+          </a:prstGeom>
+          <a:noFill/>
+          <a:ln/>
+        </p:spPr>
+        <p:txBody>
+          <a:bodyPr wrap="square" rtlCol="0" anchor="ctr"/>
+          <a:lstStyle/>
+          <a:p>
+            <a:pPr indent="0" marL="0">
+              <a:buNone/>
+            </a:pPr>
+            <a:r>
+              <a:rPr lang="en-US" sz="900" dirty="0">
+                <a:solidFill>
+                  <a:srgbClr val="999999"/>
+                </a:solidFill>
+                <a:latin typeface="Calibri" pitchFamily="34" charset="0"/>
+                <a:ea typeface="Calibri" pitchFamily="34" charset="-122"/>
+                <a:cs typeface="Calibri" pitchFamily="34" charset="-120"/>
               </a:rPr>
               <a:t>4. Sınıf DKAB — Günlük Hayattaki Dinî İfadeler</a:t>
             </a:r>
@@ -6829,7 +6936,7 @@
       </p:sp>
       <p:sp>
         <p:nvSpPr>
-          <p:cNvPr id="10" name="Text 7"/>
+          <p:cNvPr id="12" name="Text 10"/>
           <p:cNvSpPr/>
           <p:nvPr/>
         </p:nvSpPr>
@@ -6869,7 +6976,7 @@
       </p:sp>
       <p:sp>
         <p:nvSpPr>
-          <p:cNvPr id="11" name="Shape 8"/>
+          <p:cNvPr id="13" name="Shape 11"/>
           <p:cNvSpPr/>
           <p:nvPr/>
         </p:nvSpPr>
@@ -6889,7 +6996,7 @@
       </p:sp>
       <p:sp>
         <p:nvSpPr>
-          <p:cNvPr id="12" name="Shape 9"/>
+          <p:cNvPr id="14" name="Shape 12"/>
           <p:cNvSpPr/>
           <p:nvPr/>
         </p:nvSpPr>

</xml_diff>